<commit_message>
Use Work Sans for body text in the PPTX export
Canva has no Instrument Sans and substituted a serif. The PPTX now sets
body text in Work Sans, scaling each box's size so lines keep the same
width and breaks as the PDF.

Co-Authored-By: Claude Opus 5.5 <noreply@anthropic.com>
Claude-Session: https://claude.ai/code/session_01VQXvu3Xk5iBMxqhH7PwDik
</commit_message>
<xml_diff>
--- a/presentacion-metodologia-salud-bucal/Justificacion_Hipotesis_Salud_Bucal.pptx
+++ b/presentacion-metodologia-salud-bucal/Justificacion_Hipotesis_Salud_Bucal.pptx
@@ -3336,7 +3336,7 @@
         </p:nvSpPr>
         <p:spPr>
           <a:xfrm>
-            <a:off x="558800" y="4522293"/>
+            <a:off x="558800" y="4522791"/>
             <a:ext cx="5257800" cy="495300"/>
           </a:xfrm>
           <a:prstGeom prst="rect">
@@ -3356,11 +3356,11 @@
               </a:lnSpc>
             </a:pPr>
             <a:r>
-              <a:rPr b="0" i="0" sz="1300">
+              <a:rPr b="0" i="0" sz="1190">
                 <a:solidFill>
                   <a:srgbClr val="556079"/>
                 </a:solidFill>
-                <a:latin typeface="Instrument Sans"/>
+                <a:latin typeface="Work Sans"/>
               </a:rPr>
               <a:t>Disponibilidad de tiempo y hábitos de higiene bucal en estudiantes universitarios de 18 a 23 años</a:t>
             </a:r>
@@ -3711,31 +3711,31 @@
         </p:nvSpPr>
         <p:spPr>
           <a:xfrm>
-            <a:off x="558800" y="5738050"/>
-            <a:ext cx="1673791" cy="162687"/>
-          </a:xfrm>
-          <a:prstGeom prst="rect">
-            <a:avLst/>
-          </a:prstGeom>
-          <a:noFill/>
-        </p:spPr>
-        <p:txBody>
-          <a:bodyPr wrap="none" lIns="0" rIns="0" tIns="0" bIns="0" anchor="t">
-            <a:noAutofit/>
-          </a:bodyPr>
-          <a:lstStyle/>
-          <a:p>
-            <a:pPr algn="l">
-              <a:lnSpc>
-                <a:spcPct val="100000"/>
-              </a:lnSpc>
-            </a:pPr>
-            <a:r>
-              <a:rPr b="0" i="0" sz="1050">
+            <a:off x="558800" y="5752833"/>
+            <a:ext cx="1673791" cy="144501"/>
+          </a:xfrm>
+          <a:prstGeom prst="rect">
+            <a:avLst/>
+          </a:prstGeom>
+          <a:noFill/>
+        </p:spPr>
+        <p:txBody>
+          <a:bodyPr wrap="none" lIns="0" rIns="0" tIns="0" bIns="0" anchor="t">
+            <a:noAutofit/>
+          </a:bodyPr>
+          <a:lstStyle/>
+          <a:p>
+            <a:pPr algn="l">
+              <a:lnSpc>
+                <a:spcPct val="100000"/>
+              </a:lnSpc>
+            </a:pPr>
+            <a:r>
+              <a:rPr b="0" i="0" sz="969">
                 <a:solidFill>
                   <a:srgbClr val="13294B"/>
                 </a:solidFill>
-                <a:latin typeface="Instrument Sans"/>
+                <a:latin typeface="Work Sans"/>
               </a:rPr>
               <a:t>Romero Elías Esmeralda</a:t>
             </a:r>
@@ -3750,31 +3750,31 @@
         </p:nvSpPr>
         <p:spPr>
           <a:xfrm>
-            <a:off x="558800" y="5941250"/>
-            <a:ext cx="1832787" cy="162687"/>
-          </a:xfrm>
-          <a:prstGeom prst="rect">
-            <a:avLst/>
-          </a:prstGeom>
-          <a:noFill/>
-        </p:spPr>
-        <p:txBody>
-          <a:bodyPr wrap="none" lIns="0" rIns="0" tIns="0" bIns="0" anchor="t">
-            <a:noAutofit/>
-          </a:bodyPr>
-          <a:lstStyle/>
-          <a:p>
-            <a:pPr algn="l">
-              <a:lnSpc>
-                <a:spcPct val="100000"/>
-              </a:lnSpc>
-            </a:pPr>
-            <a:r>
-              <a:rPr b="0" i="0" sz="1050">
+            <a:off x="558800" y="5951308"/>
+            <a:ext cx="1832787" cy="150460"/>
+          </a:xfrm>
+          <a:prstGeom prst="rect">
+            <a:avLst/>
+          </a:prstGeom>
+          <a:noFill/>
+        </p:spPr>
+        <p:txBody>
+          <a:bodyPr wrap="none" lIns="0" rIns="0" tIns="0" bIns="0" anchor="t">
+            <a:noAutofit/>
+          </a:bodyPr>
+          <a:lstStyle/>
+          <a:p>
+            <a:pPr algn="l">
+              <a:lnSpc>
+                <a:spcPct val="100000"/>
+              </a:lnSpc>
+            </a:pPr>
+            <a:r>
+              <a:rPr b="0" i="0" sz="1010">
                 <a:solidFill>
                   <a:srgbClr val="13294B"/>
                 </a:solidFill>
-                <a:latin typeface="Instrument Sans"/>
+                <a:latin typeface="Work Sans"/>
               </a:rPr>
               <a:t>Rodríguez Esquivel Megan</a:t>
             </a:r>
@@ -3789,31 +3789,31 @@
         </p:nvSpPr>
         <p:spPr>
           <a:xfrm>
-            <a:off x="558800" y="6144450"/>
-            <a:ext cx="1718293" cy="162687"/>
-          </a:xfrm>
-          <a:prstGeom prst="rect">
-            <a:avLst/>
-          </a:prstGeom>
-          <a:noFill/>
-        </p:spPr>
-        <p:txBody>
-          <a:bodyPr wrap="none" lIns="0" rIns="0" tIns="0" bIns="0" anchor="t">
-            <a:noAutofit/>
-          </a:bodyPr>
-          <a:lstStyle/>
-          <a:p>
-            <a:pPr algn="l">
-              <a:lnSpc>
-                <a:spcPct val="100000"/>
-              </a:lnSpc>
-            </a:pPr>
-            <a:r>
-              <a:rPr b="0" i="0" sz="1050">
+            <a:off x="558800" y="6156871"/>
+            <a:ext cx="1718293" cy="147481"/>
+          </a:xfrm>
+          <a:prstGeom prst="rect">
+            <a:avLst/>
+          </a:prstGeom>
+          <a:noFill/>
+        </p:spPr>
+        <p:txBody>
+          <a:bodyPr wrap="none" lIns="0" rIns="0" tIns="0" bIns="0" anchor="t">
+            <a:noAutofit/>
+          </a:bodyPr>
+          <a:lstStyle/>
+          <a:p>
+            <a:pPr algn="l">
+              <a:lnSpc>
+                <a:spcPct val="100000"/>
+              </a:lnSpc>
+            </a:pPr>
+            <a:r>
+              <a:rPr b="0" i="0" sz="990">
                 <a:solidFill>
                   <a:srgbClr val="13294B"/>
                 </a:solidFill>
-                <a:latin typeface="Instrument Sans"/>
+                <a:latin typeface="Work Sans"/>
               </a:rPr>
               <a:t>Nolasco Mejia Luis Diego</a:t>
             </a:r>
@@ -3828,31 +3828,31 @@
         </p:nvSpPr>
         <p:spPr>
           <a:xfrm>
-            <a:off x="2692400" y="5738050"/>
-            <a:ext cx="1405774" cy="162687"/>
-          </a:xfrm>
-          <a:prstGeom prst="rect">
-            <a:avLst/>
-          </a:prstGeom>
-          <a:noFill/>
-        </p:spPr>
-        <p:txBody>
-          <a:bodyPr wrap="none" lIns="0" rIns="0" tIns="0" bIns="0" anchor="t">
-            <a:noAutofit/>
-          </a:bodyPr>
-          <a:lstStyle/>
-          <a:p>
-            <a:pPr algn="l">
-              <a:lnSpc>
-                <a:spcPct val="100000"/>
-              </a:lnSpc>
-            </a:pPr>
-            <a:r>
-              <a:rPr b="0" i="0" sz="1050">
+            <a:off x="2692400" y="5752833"/>
+            <a:ext cx="1405774" cy="144501"/>
+          </a:xfrm>
+          <a:prstGeom prst="rect">
+            <a:avLst/>
+          </a:prstGeom>
+          <a:noFill/>
+        </p:spPr>
+        <p:txBody>
+          <a:bodyPr wrap="none" lIns="0" rIns="0" tIns="0" bIns="0" anchor="t">
+            <a:noAutofit/>
+          </a:bodyPr>
+          <a:lstStyle/>
+          <a:p>
+            <a:pPr algn="l">
+              <a:lnSpc>
+                <a:spcPct val="100000"/>
+              </a:lnSpc>
+            </a:pPr>
+            <a:r>
+              <a:rPr b="0" i="0" sz="969">
                 <a:solidFill>
                   <a:srgbClr val="13294B"/>
                 </a:solidFill>
-                <a:latin typeface="Instrument Sans"/>
+                <a:latin typeface="Work Sans"/>
               </a:rPr>
               <a:t>Esquivel Soria Pablo</a:t>
             </a:r>
@@ -3867,31 +3867,31 @@
         </p:nvSpPr>
         <p:spPr>
           <a:xfrm>
-            <a:off x="2692400" y="5941250"/>
-            <a:ext cx="1911133" cy="162687"/>
-          </a:xfrm>
-          <a:prstGeom prst="rect">
-            <a:avLst/>
-          </a:prstGeom>
-          <a:noFill/>
-        </p:spPr>
-        <p:txBody>
-          <a:bodyPr wrap="none" lIns="0" rIns="0" tIns="0" bIns="0" anchor="t">
-            <a:noAutofit/>
-          </a:bodyPr>
-          <a:lstStyle/>
-          <a:p>
-            <a:pPr algn="l">
-              <a:lnSpc>
-                <a:spcPct val="100000"/>
-              </a:lnSpc>
-            </a:pPr>
-            <a:r>
-              <a:rPr b="0" i="0" sz="1050">
+            <a:off x="2692400" y="5952490"/>
+            <a:ext cx="1911133" cy="148971"/>
+          </a:xfrm>
+          <a:prstGeom prst="rect">
+            <a:avLst/>
+          </a:prstGeom>
+          <a:noFill/>
+        </p:spPr>
+        <p:txBody>
+          <a:bodyPr wrap="none" lIns="0" rIns="0" tIns="0" bIns="0" anchor="t">
+            <a:noAutofit/>
+          </a:bodyPr>
+          <a:lstStyle/>
+          <a:p>
+            <a:pPr algn="l">
+              <a:lnSpc>
+                <a:spcPct val="100000"/>
+              </a:lnSpc>
+            </a:pPr>
+            <a:r>
+              <a:rPr b="0" i="0" sz="1000">
                 <a:solidFill>
                   <a:srgbClr val="13294B"/>
                 </a:solidFill>
-                <a:latin typeface="Instrument Sans"/>
+                <a:latin typeface="Work Sans"/>
               </a:rPr>
               <a:t>Rodríguez Hernández Tania</a:t>
             </a:r>
@@ -3945,31 +3945,31 @@
         </p:nvSpPr>
         <p:spPr>
           <a:xfrm>
-            <a:off x="5334000" y="5738050"/>
-            <a:ext cx="1656941" cy="162687"/>
-          </a:xfrm>
-          <a:prstGeom prst="rect">
-            <a:avLst/>
-          </a:prstGeom>
-          <a:noFill/>
-        </p:spPr>
-        <p:txBody>
-          <a:bodyPr wrap="none" lIns="0" rIns="0" tIns="0" bIns="0" anchor="t">
-            <a:noAutofit/>
-          </a:bodyPr>
-          <a:lstStyle/>
-          <a:p>
-            <a:pPr algn="l">
-              <a:lnSpc>
-                <a:spcPct val="100000"/>
-              </a:lnSpc>
-            </a:pPr>
-            <a:r>
-              <a:rPr b="0" i="0" sz="1050">
+            <a:off x="5334000" y="5749290"/>
+            <a:ext cx="1656941" cy="148971"/>
+          </a:xfrm>
+          <a:prstGeom prst="rect">
+            <a:avLst/>
+          </a:prstGeom>
+          <a:noFill/>
+        </p:spPr>
+        <p:txBody>
+          <a:bodyPr wrap="none" lIns="0" rIns="0" tIns="0" bIns="0" anchor="t">
+            <a:noAutofit/>
+          </a:bodyPr>
+          <a:lstStyle/>
+          <a:p>
+            <a:pPr algn="l">
+              <a:lnSpc>
+                <a:spcPct val="100000"/>
+              </a:lnSpc>
+            </a:pPr>
+            <a:r>
+              <a:rPr b="0" i="0" sz="1000">
                 <a:solidFill>
                   <a:srgbClr val="13294B"/>
                 </a:solidFill>
-                <a:latin typeface="Instrument Sans"/>
+                <a:latin typeface="Work Sans"/>
               </a:rPr>
               <a:t>Chávez Martínez Martín</a:t>
             </a:r>
@@ -4023,31 +4023,31 @@
         </p:nvSpPr>
         <p:spPr>
           <a:xfrm>
-            <a:off x="7416800" y="5738050"/>
-            <a:ext cx="1660830" cy="162687"/>
-          </a:xfrm>
-          <a:prstGeom prst="rect">
-            <a:avLst/>
-          </a:prstGeom>
-          <a:noFill/>
-        </p:spPr>
-        <p:txBody>
-          <a:bodyPr wrap="none" lIns="0" rIns="0" tIns="0" bIns="0" anchor="t">
-            <a:noAutofit/>
-          </a:bodyPr>
-          <a:lstStyle/>
-          <a:p>
-            <a:pPr algn="l">
-              <a:lnSpc>
-                <a:spcPct val="100000"/>
-              </a:lnSpc>
-            </a:pPr>
-            <a:r>
-              <a:rPr b="0" i="0" sz="1050">
+            <a:off x="7416800" y="5752833"/>
+            <a:ext cx="1660830" cy="144501"/>
+          </a:xfrm>
+          <a:prstGeom prst="rect">
+            <a:avLst/>
+          </a:prstGeom>
+          <a:noFill/>
+        </p:spPr>
+        <p:txBody>
+          <a:bodyPr wrap="none" lIns="0" rIns="0" tIns="0" bIns="0" anchor="t">
+            <a:noAutofit/>
+          </a:bodyPr>
+          <a:lstStyle/>
+          <a:p>
+            <a:pPr algn="l">
+              <a:lnSpc>
+                <a:spcPct val="100000"/>
+              </a:lnSpc>
+            </a:pPr>
+            <a:r>
+              <a:rPr b="0" i="0" sz="969">
                 <a:solidFill>
                   <a:srgbClr val="13294B"/>
                 </a:solidFill>
-                <a:latin typeface="Instrument Sans"/>
+                <a:latin typeface="Work Sans"/>
               </a:rPr>
               <a:t>Taller de Investigación II</a:t>
             </a:r>
@@ -4062,31 +4062,31 @@
         </p:nvSpPr>
         <p:spPr>
           <a:xfrm>
-            <a:off x="7416800" y="5941250"/>
-            <a:ext cx="1329588" cy="162687"/>
-          </a:xfrm>
-          <a:prstGeom prst="rect">
-            <a:avLst/>
-          </a:prstGeom>
-          <a:noFill/>
-        </p:spPr>
-        <p:txBody>
-          <a:bodyPr wrap="none" lIns="0" rIns="0" tIns="0" bIns="0" anchor="t">
-            <a:noAutofit/>
-          </a:bodyPr>
-          <a:lstStyle/>
-          <a:p>
-            <a:pPr algn="l">
-              <a:lnSpc>
-                <a:spcPct val="100000"/>
-              </a:lnSpc>
-            </a:pPr>
-            <a:r>
-              <a:rPr b="0" i="0" sz="1050">
+            <a:off x="7416800" y="5957214"/>
+            <a:ext cx="1329588" cy="143012"/>
+          </a:xfrm>
+          <a:prstGeom prst="rect">
+            <a:avLst/>
+          </a:prstGeom>
+          <a:noFill/>
+        </p:spPr>
+        <p:txBody>
+          <a:bodyPr wrap="none" lIns="0" rIns="0" tIns="0" bIns="0" anchor="t">
+            <a:noAutofit/>
+          </a:bodyPr>
+          <a:lstStyle/>
+          <a:p>
+            <a:pPr algn="l">
+              <a:lnSpc>
+                <a:spcPct val="100000"/>
+              </a:lnSpc>
+            </a:pPr>
+            <a:r>
+              <a:rPr b="0" i="0" sz="960">
                 <a:solidFill>
                   <a:srgbClr val="13294B"/>
                 </a:solidFill>
-                <a:latin typeface="Instrument Sans"/>
+                <a:latin typeface="Work Sans"/>
               </a:rPr>
               <a:t>Unidad II · Proyecto</a:t>
             </a:r>
@@ -4140,31 +4140,31 @@
         </p:nvSpPr>
         <p:spPr>
           <a:xfrm>
-            <a:off x="9652000" y="5738050"/>
-            <a:ext cx="1185570" cy="162687"/>
-          </a:xfrm>
-          <a:prstGeom prst="rect">
-            <a:avLst/>
-          </a:prstGeom>
-          <a:noFill/>
-        </p:spPr>
-        <p:txBody>
-          <a:bodyPr wrap="none" lIns="0" rIns="0" tIns="0" bIns="0" anchor="t">
-            <a:noAutofit/>
-          </a:bodyPr>
-          <a:lstStyle/>
-          <a:p>
-            <a:pPr algn="l">
-              <a:lnSpc>
-                <a:spcPct val="100000"/>
-              </a:lnSpc>
-            </a:pPr>
-            <a:r>
-              <a:rPr b="0" i="0" sz="1050">
+            <a:off x="9652000" y="5751652"/>
+            <a:ext cx="1185570" cy="145991"/>
+          </a:xfrm>
+          <a:prstGeom prst="rect">
+            <a:avLst/>
+          </a:prstGeom>
+          <a:noFill/>
+        </p:spPr>
+        <p:txBody>
+          <a:bodyPr wrap="none" lIns="0" rIns="0" tIns="0" bIns="0" anchor="t">
+            <a:noAutofit/>
+          </a:bodyPr>
+          <a:lstStyle/>
+          <a:p>
+            <a:pPr algn="l">
+              <a:lnSpc>
+                <a:spcPct val="100000"/>
+              </a:lnSpc>
+            </a:pPr>
+            <a:r>
+              <a:rPr b="0" i="0" sz="980">
                 <a:solidFill>
                   <a:srgbClr val="13294B"/>
                 </a:solidFill>
-                <a:latin typeface="Instrument Sans"/>
+                <a:latin typeface="Work Sans"/>
               </a:rPr>
               <a:t>Cd. Juárez, Chih.</a:t>
             </a:r>
@@ -4179,31 +4179,31 @@
         </p:nvSpPr>
         <p:spPr>
           <a:xfrm>
-            <a:off x="9652000" y="5941250"/>
-            <a:ext cx="1532798" cy="162687"/>
-          </a:xfrm>
-          <a:prstGeom prst="rect">
-            <a:avLst/>
-          </a:prstGeom>
-          <a:noFill/>
-        </p:spPr>
-        <p:txBody>
-          <a:bodyPr wrap="none" lIns="0" rIns="0" tIns="0" bIns="0" anchor="t">
-            <a:noAutofit/>
-          </a:bodyPr>
-          <a:lstStyle/>
-          <a:p>
-            <a:pPr algn="l">
-              <a:lnSpc>
-                <a:spcPct val="100000"/>
-              </a:lnSpc>
-            </a:pPr>
-            <a:r>
-              <a:rPr b="0" i="0" sz="1050">
+            <a:off x="9652000" y="5956033"/>
+            <a:ext cx="1532798" cy="144501"/>
+          </a:xfrm>
+          <a:prstGeom prst="rect">
+            <a:avLst/>
+          </a:prstGeom>
+          <a:noFill/>
+        </p:spPr>
+        <p:txBody>
+          <a:bodyPr wrap="none" lIns="0" rIns="0" tIns="0" bIns="0" anchor="t">
+            <a:noAutofit/>
+          </a:bodyPr>
+          <a:lstStyle/>
+          <a:p>
+            <a:pPr algn="l">
+              <a:lnSpc>
+                <a:spcPct val="100000"/>
+              </a:lnSpc>
+            </a:pPr>
+            <a:r>
+              <a:rPr b="0" i="0" sz="969">
                 <a:solidFill>
                   <a:srgbClr val="13294B"/>
                 </a:solidFill>
-                <a:latin typeface="Instrument Sans"/>
+                <a:latin typeface="Work Sans"/>
               </a:rPr>
               <a:t>14 de octubre de 2026</a:t>
             </a:r>
@@ -4611,8 +4611,8 @@
         </p:nvSpPr>
         <p:spPr>
           <a:xfrm>
-            <a:off x="776985" y="2202815"/>
-            <a:ext cx="156644" cy="232410"/>
+            <a:off x="776985" y="2210435"/>
+            <a:ext cx="156644" cy="223456"/>
           </a:xfrm>
           <a:prstGeom prst="rect">
             <a:avLst/>
@@ -4635,7 +4635,7 @@
                 <a:solidFill>
                   <a:srgbClr val="C8372D"/>
                 </a:solidFill>
-                <a:latin typeface="Instrument Sans"/>
+                <a:latin typeface="Work Sans"/>
               </a:rPr>
               <a:t>1</a:t>
             </a:r>
@@ -4689,7 +4689,7 @@
         </p:nvSpPr>
         <p:spPr>
           <a:xfrm>
-            <a:off x="1117600" y="2164985"/>
+            <a:off x="1117600" y="2165398"/>
             <a:ext cx="4865370" cy="419100"/>
           </a:xfrm>
           <a:prstGeom prst="rect">
@@ -4709,11 +4709,11 @@
               </a:lnSpc>
             </a:pPr>
             <a:r>
-              <a:rPr b="0" i="0" sz="1050">
+              <a:rPr b="0" i="0" sz="950">
                 <a:solidFill>
                   <a:srgbClr val="13294B"/>
                 </a:solidFill>
-                <a:latin typeface="Instrument Sans"/>
+                <a:latin typeface="Work Sans"/>
               </a:rPr>
               <a:t>Existe una relación significativa y directa entre el tiempo disponible y la frecuencia y calidad del cepillado dental.</a:t>
             </a:r>
@@ -4767,8 +4767,8 @@
         </p:nvSpPr>
         <p:spPr>
           <a:xfrm>
-            <a:off x="776985" y="3098165"/>
-            <a:ext cx="213222" cy="232410"/>
+            <a:off x="776985" y="3105785"/>
+            <a:ext cx="213222" cy="223456"/>
           </a:xfrm>
           <a:prstGeom prst="rect">
             <a:avLst/>
@@ -4791,7 +4791,7 @@
                 <a:solidFill>
                   <a:srgbClr val="556079"/>
                 </a:solidFill>
-                <a:latin typeface="Instrument Sans"/>
+                <a:latin typeface="Work Sans"/>
               </a:rPr>
               <a:t>0</a:t>
             </a:r>
@@ -4845,7 +4845,7 @@
         </p:nvSpPr>
         <p:spPr>
           <a:xfrm>
-            <a:off x="1117600" y="3060335"/>
+            <a:off x="1117600" y="3060748"/>
             <a:ext cx="4865370" cy="419100"/>
           </a:xfrm>
           <a:prstGeom prst="rect">
@@ -4865,11 +4865,11 @@
               </a:lnSpc>
             </a:pPr>
             <a:r>
-              <a:rPr b="0" i="0" sz="1050">
+              <a:rPr b="0" i="0" sz="960">
                 <a:solidFill>
                   <a:srgbClr val="13294B"/>
                 </a:solidFill>
-                <a:latin typeface="Instrument Sans"/>
+                <a:latin typeface="Work Sans"/>
               </a:rPr>
               <a:t>No existe una relación significativa entre el tiempo disponible y los hábitos de higiene bucal.</a:t>
             </a:r>
@@ -4923,7 +4923,7 @@
         </p:nvSpPr>
         <p:spPr>
           <a:xfrm>
-            <a:off x="1117600" y="3790585"/>
+            <a:off x="1117600" y="3790998"/>
             <a:ext cx="4865370" cy="419100"/>
           </a:xfrm>
           <a:prstGeom prst="rect">
@@ -4943,11 +4943,11 @@
               </a:lnSpc>
             </a:pPr>
             <a:r>
-              <a:rPr b="0" i="0" sz="1050">
+              <a:rPr b="0" i="0" sz="950">
                 <a:solidFill>
                   <a:srgbClr val="13294B"/>
                 </a:solidFill>
-                <a:latin typeface="Instrument Sans"/>
+                <a:latin typeface="Work Sans"/>
               </a:rPr>
               <a:t>Análisis de correlación entre las horas disponibles y la frecuencia y calidad del cepillado, con datos de una encuesta a estudiantes de 18 a 23 años.</a:t>
             </a:r>
@@ -5040,31 +5040,31 @@
         </p:nvSpPr>
         <p:spPr>
           <a:xfrm>
-            <a:off x="2038159" y="5560631"/>
-            <a:ext cx="1199266" cy="178181"/>
-          </a:xfrm>
-          <a:prstGeom prst="rect">
-            <a:avLst/>
-          </a:prstGeom>
-          <a:noFill/>
-        </p:spPr>
-        <p:txBody>
-          <a:bodyPr wrap="none" lIns="0" rIns="0" tIns="0" bIns="0" anchor="t">
-            <a:noAutofit/>
-          </a:bodyPr>
-          <a:lstStyle/>
-          <a:p>
-            <a:pPr algn="l">
-              <a:lnSpc>
-                <a:spcPct val="100000"/>
-              </a:lnSpc>
-            </a:pPr>
-            <a:r>
-              <a:rPr b="0" i="0" sz="1150">
+            <a:off x="2038159" y="5587733"/>
+            <a:ext cx="1199266" cy="144501"/>
+          </a:xfrm>
+          <a:prstGeom prst="rect">
+            <a:avLst/>
+          </a:prstGeom>
+          <a:noFill/>
+        </p:spPr>
+        <p:txBody>
+          <a:bodyPr wrap="none" lIns="0" rIns="0" tIns="0" bIns="0" anchor="t">
+            <a:noAutofit/>
+          </a:bodyPr>
+          <a:lstStyle/>
+          <a:p>
+            <a:pPr algn="l">
+              <a:lnSpc>
+                <a:spcPct val="100000"/>
+              </a:lnSpc>
+            </a:pPr>
+            <a:r>
+              <a:rPr b="0" i="0" sz="969">
                 <a:solidFill>
                   <a:srgbClr val="13294B"/>
                 </a:solidFill>
-                <a:latin typeface="Instrument Sans"/>
+                <a:latin typeface="Work Sans"/>
               </a:rPr>
               <a:t>   →   se rechaza </a:t>
             </a:r>
@@ -5118,8 +5118,8 @@
         </p:nvSpPr>
         <p:spPr>
           <a:xfrm>
-            <a:off x="3192208" y="5648007"/>
-            <a:ext cx="144711" cy="116205"/>
+            <a:off x="3192208" y="5651817"/>
+            <a:ext cx="144711" cy="111728"/>
           </a:xfrm>
           <a:prstGeom prst="rect">
             <a:avLst/>
@@ -5142,7 +5142,7 @@
                 <a:solidFill>
                   <a:srgbClr val="13294B"/>
                 </a:solidFill>
-                <a:latin typeface="Instrument Sans"/>
+                <a:latin typeface="Work Sans"/>
               </a:rPr>
               <a:t>0</a:t>
             </a:r>
@@ -5157,31 +5157,31 @@
         </p:nvSpPr>
         <p:spPr>
           <a:xfrm>
-            <a:off x="3293745" y="5560631"/>
-            <a:ext cx="1836984" cy="178181"/>
-          </a:xfrm>
-          <a:prstGeom prst="rect">
-            <a:avLst/>
-          </a:prstGeom>
-          <a:noFill/>
-        </p:spPr>
-        <p:txBody>
-          <a:bodyPr wrap="none" lIns="0" rIns="0" tIns="0" bIns="0" anchor="t">
-            <a:noAutofit/>
-          </a:bodyPr>
-          <a:lstStyle/>
-          <a:p>
-            <a:pPr algn="l">
-              <a:lnSpc>
-                <a:spcPct val="100000"/>
-              </a:lnSpc>
-            </a:pPr>
-            <a:r>
-              <a:rPr b="0" i="0" sz="1150">
+            <a:off x="3293745" y="5579465"/>
+            <a:ext cx="1836984" cy="154929"/>
+          </a:xfrm>
+          <a:prstGeom prst="rect">
+            <a:avLst/>
+          </a:prstGeom>
+          <a:noFill/>
+        </p:spPr>
+        <p:txBody>
+          <a:bodyPr wrap="none" lIns="0" rIns="0" tIns="0" bIns="0" anchor="t">
+            <a:noAutofit/>
+          </a:bodyPr>
+          <a:lstStyle/>
+          <a:p>
+            <a:pPr algn="l">
+              <a:lnSpc>
+                <a:spcPct val="100000"/>
+              </a:lnSpc>
+            </a:pPr>
+            <a:r>
+              <a:rPr b="0" i="0" sz="1040">
                 <a:solidFill>
                   <a:srgbClr val="13294B"/>
                 </a:solidFill>
-                <a:latin typeface="Instrument Sans"/>
+                <a:latin typeface="Work Sans"/>
               </a:rPr>
               <a:t>y se sostiene la hipótesis</a:t>
             </a:r>
@@ -6369,31 +6369,31 @@
         </p:nvSpPr>
         <p:spPr>
           <a:xfrm>
-            <a:off x="787400" y="3732212"/>
-            <a:ext cx="2544222" cy="193675"/>
-          </a:xfrm>
-          <a:prstGeom prst="rect">
-            <a:avLst/>
-          </a:prstGeom>
-          <a:noFill/>
-        </p:spPr>
-        <p:txBody>
-          <a:bodyPr wrap="none" lIns="0" rIns="0" tIns="0" bIns="0" anchor="t">
-            <a:noAutofit/>
-          </a:bodyPr>
-          <a:lstStyle/>
-          <a:p>
-            <a:pPr algn="l">
-              <a:lnSpc>
-                <a:spcPct val="100000"/>
-              </a:lnSpc>
-            </a:pPr>
-            <a:r>
-              <a:rPr b="1" i="0" sz="1250">
+            <a:off x="787400" y="3740924"/>
+            <a:ext cx="2544222" cy="183234"/>
+          </a:xfrm>
+          <a:prstGeom prst="rect">
+            <a:avLst/>
+          </a:prstGeom>
+          <a:noFill/>
+        </p:spPr>
+        <p:txBody>
+          <a:bodyPr wrap="none" lIns="0" rIns="0" tIns="0" bIns="0" anchor="t">
+            <a:noAutofit/>
+          </a:bodyPr>
+          <a:lstStyle/>
+          <a:p>
+            <a:pPr algn="l">
+              <a:lnSpc>
+                <a:spcPct val="100000"/>
+              </a:lnSpc>
+            </a:pPr>
+            <a:r>
+              <a:rPr b="1" i="0" sz="1230">
                 <a:solidFill>
                   <a:srgbClr val="13294B"/>
                 </a:solidFill>
-                <a:latin typeface="Instrument Sans"/>
+                <a:latin typeface="Work Sans"/>
               </a:rPr>
               <a:t>Campañas de concientización</a:t>
             </a:r>
@@ -6408,7 +6408,7 @@
         </p:nvSpPr>
         <p:spPr>
           <a:xfrm>
-            <a:off x="787400" y="4019185"/>
+            <a:off x="787400" y="4019598"/>
             <a:ext cx="3191002" cy="419100"/>
           </a:xfrm>
           <a:prstGeom prst="rect">
@@ -6428,11 +6428,11 @@
               </a:lnSpc>
             </a:pPr>
             <a:r>
-              <a:rPr b="0" i="0" sz="1050">
+              <a:rPr b="0" i="0" sz="960">
                 <a:solidFill>
                   <a:srgbClr val="556079"/>
                 </a:solidFill>
-                <a:latin typeface="Instrument Sans"/>
+                <a:latin typeface="Work Sans"/>
               </a:rPr>
               <a:t>Sobre la importancia del cepillado y la organización del tiempo durante la jornada.</a:t>
             </a:r>
@@ -6525,31 +6525,31 @@
         </p:nvSpPr>
         <p:spPr>
           <a:xfrm>
-            <a:off x="4559300" y="3732212"/>
-            <a:ext cx="2172690" cy="193675"/>
-          </a:xfrm>
-          <a:prstGeom prst="rect">
-            <a:avLst/>
-          </a:prstGeom>
-          <a:noFill/>
-        </p:spPr>
-        <p:txBody>
-          <a:bodyPr wrap="none" lIns="0" rIns="0" tIns="0" bIns="0" anchor="t">
-            <a:noAutofit/>
-          </a:bodyPr>
-          <a:lstStyle/>
-          <a:p>
-            <a:pPr algn="l">
-              <a:lnSpc>
-                <a:spcPct val="100000"/>
-              </a:lnSpc>
-            </a:pPr>
-            <a:r>
-              <a:rPr b="1" i="0" sz="1250">
+            <a:off x="4559300" y="3745649"/>
+            <a:ext cx="2172690" cy="177275"/>
+          </a:xfrm>
+          <a:prstGeom prst="rect">
+            <a:avLst/>
+          </a:prstGeom>
+          <a:noFill/>
+        </p:spPr>
+        <p:txBody>
+          <a:bodyPr wrap="none" lIns="0" rIns="0" tIns="0" bIns="0" anchor="t">
+            <a:noAutofit/>
+          </a:bodyPr>
+          <a:lstStyle/>
+          <a:p>
+            <a:pPr algn="l">
+              <a:lnSpc>
+                <a:spcPct val="100000"/>
+              </a:lnSpc>
+            </a:pPr>
+            <a:r>
+              <a:rPr b="1" i="0" sz="1190">
                 <a:solidFill>
                   <a:srgbClr val="13294B"/>
                 </a:solidFill>
-                <a:latin typeface="Instrument Sans"/>
+                <a:latin typeface="Work Sans"/>
               </a:rPr>
               <a:t>Espacios para el cepillado</a:t>
             </a:r>
@@ -6564,7 +6564,7 @@
         </p:nvSpPr>
         <p:spPr>
           <a:xfrm>
-            <a:off x="4559300" y="4019185"/>
+            <a:off x="4559300" y="4019598"/>
             <a:ext cx="3191002" cy="419100"/>
           </a:xfrm>
           <a:prstGeom prst="rect">
@@ -6584,11 +6584,11 @@
               </a:lnSpc>
             </a:pPr>
             <a:r>
-              <a:rPr b="0" i="0" sz="1050">
+              <a:rPr b="0" i="0" sz="960">
                 <a:solidFill>
                   <a:srgbClr val="556079"/>
                 </a:solidFill>
-                <a:latin typeface="Instrument Sans"/>
+                <a:latin typeface="Work Sans"/>
               </a:rPr>
               <a:t>Lugares accesibles para lavarse los dientes dentro de las instalaciones.</a:t>
             </a:r>
@@ -6681,31 +6681,31 @@
         </p:nvSpPr>
         <p:spPr>
           <a:xfrm>
-            <a:off x="8331200" y="3732212"/>
-            <a:ext cx="1769954" cy="193675"/>
-          </a:xfrm>
-          <a:prstGeom prst="rect">
-            <a:avLst/>
-          </a:prstGeom>
-          <a:noFill/>
-        </p:spPr>
-        <p:txBody>
-          <a:bodyPr wrap="none" lIns="0" rIns="0" tIns="0" bIns="0" anchor="t">
-            <a:noAutofit/>
-          </a:bodyPr>
-          <a:lstStyle/>
-          <a:p>
-            <a:pPr algn="l">
-              <a:lnSpc>
-                <a:spcPct val="100000"/>
-              </a:lnSpc>
-            </a:pPr>
-            <a:r>
-              <a:rPr b="1" i="0" sz="1250">
+            <a:off x="8331200" y="3742105"/>
+            <a:ext cx="1769954" cy="181744"/>
+          </a:xfrm>
+          <a:prstGeom prst="rect">
+            <a:avLst/>
+          </a:prstGeom>
+          <a:noFill/>
+        </p:spPr>
+        <p:txBody>
+          <a:bodyPr wrap="none" lIns="0" rIns="0" tIns="0" bIns="0" anchor="t">
+            <a:noAutofit/>
+          </a:bodyPr>
+          <a:lstStyle/>
+          <a:p>
+            <a:pPr algn="l">
+              <a:lnSpc>
+                <a:spcPct val="100000"/>
+              </a:lnSpc>
+            </a:pPr>
+            <a:r>
+              <a:rPr b="1" i="0" sz="1220">
                 <a:solidFill>
                   <a:srgbClr val="13294B"/>
                 </a:solidFill>
-                <a:latin typeface="Instrument Sans"/>
+                <a:latin typeface="Work Sans"/>
               </a:rPr>
               <a:t>Orientación práctica</a:t>
             </a:r>
@@ -6720,7 +6720,7 @@
         </p:nvSpPr>
         <p:spPr>
           <a:xfrm>
-            <a:off x="8331200" y="4019185"/>
+            <a:off x="8331200" y="4019598"/>
             <a:ext cx="3191002" cy="419100"/>
           </a:xfrm>
           <a:prstGeom prst="rect">
@@ -6740,11 +6740,11 @@
               </a:lnSpc>
             </a:pPr>
             <a:r>
-              <a:rPr b="0" i="0" sz="1050">
+              <a:rPr b="0" i="0" sz="969">
                 <a:solidFill>
                   <a:srgbClr val="556079"/>
                 </a:solidFill>
-                <a:latin typeface="Instrument Sans"/>
+                <a:latin typeface="Work Sans"/>
               </a:rPr>
               <a:t>Técnicas de cepillado eficientes para mantener la higiene aun con poco tiempo.</a:t>
             </a:r>
@@ -7152,7 +7152,7 @@
         </p:nvSpPr>
         <p:spPr>
           <a:xfrm>
-            <a:off x="990600" y="1880536"/>
+            <a:off x="990600" y="1880964"/>
             <a:ext cx="10987278" cy="431800"/>
           </a:xfrm>
           <a:prstGeom prst="rect">
@@ -7172,11 +7172,11 @@
               </a:lnSpc>
             </a:pPr>
             <a:r>
-              <a:rPr b="0" i="0" sz="1100">
+              <a:rPr b="0" i="0" sz="1019">
                 <a:solidFill>
                   <a:srgbClr val="13294B"/>
                 </a:solidFill>
-                <a:latin typeface="Instrument Sans"/>
+                <a:latin typeface="Work Sans"/>
               </a:rPr>
               <a:t>Deinzer, R., Hilpert, D., Bach, K., Schawacht, M., &amp; Herforth, A. (2001). Effects of academic stress on oral hygiene—A potential link between stress and plaque-associated disease? Journal of Clinical Periodontology, 28(5), 459–464.</a:t>
             </a:r>
@@ -7230,7 +7230,7 @@
         </p:nvSpPr>
         <p:spPr>
           <a:xfrm>
-            <a:off x="990600" y="2401236"/>
+            <a:off x="990600" y="2401664"/>
             <a:ext cx="10987278" cy="431800"/>
           </a:xfrm>
           <a:prstGeom prst="rect">
@@ -7250,11 +7250,11 @@
               </a:lnSpc>
             </a:pPr>
             <a:r>
-              <a:rPr b="0" i="0" sz="1100">
+              <a:rPr b="0" i="0" sz="1010">
                 <a:solidFill>
                   <a:srgbClr val="13294B"/>
                 </a:solidFill>
-                <a:latin typeface="Instrument Sans"/>
+                <a:latin typeface="Work Sans"/>
               </a:rPr>
               <a:t>de Isabel, V. (2026). La salud bucodental en universitarios: el eslabón olvidado del bienestar académico. Blog de ISAG [en línea]. Usal.es. Consultado el 16 de septiembre de 2026.</a:t>
             </a:r>
@@ -7308,7 +7308,7 @@
         </p:nvSpPr>
         <p:spPr>
           <a:xfrm>
-            <a:off x="990600" y="2921936"/>
+            <a:off x="990600" y="2922364"/>
             <a:ext cx="10987278" cy="431800"/>
           </a:xfrm>
           <a:prstGeom prst="rect">
@@ -7328,11 +7328,11 @@
               </a:lnSpc>
             </a:pPr>
             <a:r>
-              <a:rPr b="0" i="0" sz="1100">
+              <a:rPr b="0" i="0" sz="1030">
                 <a:solidFill>
                   <a:srgbClr val="13294B"/>
                 </a:solidFill>
-                <a:latin typeface="Instrument Sans"/>
+                <a:latin typeface="Work Sans"/>
               </a:rPr>
               <a:t>DGCS-UNAM (2025). En México, 95 por ciento de la población padece caries o enfermedades en las encías. Boletín DGCS. https://www.dgcs.unam.mx/boletin/bdboletin/2025_184.html</a:t>
             </a:r>
@@ -7386,7 +7386,7 @@
         </p:nvSpPr>
         <p:spPr>
           <a:xfrm>
-            <a:off x="990600" y="3442636"/>
+            <a:off x="990600" y="3443064"/>
             <a:ext cx="10987278" cy="431800"/>
           </a:xfrm>
           <a:prstGeom prst="rect">
@@ -7406,11 +7406,11 @@
               </a:lnSpc>
             </a:pPr>
             <a:r>
-              <a:rPr b="0" i="0" sz="1100">
+              <a:rPr b="0" i="0" sz="1030">
                 <a:solidFill>
                   <a:srgbClr val="13294B"/>
                 </a:solidFill>
-                <a:latin typeface="Instrument Sans"/>
+                <a:latin typeface="Work Sans"/>
               </a:rPr>
               <a:t>Hábitos de higiene bucal y su influencia sobre la frecuencia de caries. Universidad Nacional de Loja, Ecuador. https://dspace.unl.edu.ec/items/f83a95b0-cf2c-4758-8cfa-285621764e9b</a:t>
             </a:r>
@@ -7464,7 +7464,7 @@
         </p:nvSpPr>
         <p:spPr>
           <a:xfrm>
-            <a:off x="990600" y="3963336"/>
+            <a:off x="990600" y="3963764"/>
             <a:ext cx="10987278" cy="431800"/>
           </a:xfrm>
           <a:prstGeom prst="rect">
@@ -7484,11 +7484,11 @@
               </a:lnSpc>
             </a:pPr>
             <a:r>
-              <a:rPr b="0" i="0" sz="1100">
+              <a:rPr b="0" i="0" sz="1040">
                 <a:solidFill>
                   <a:srgbClr val="13294B"/>
                 </a:solidFill>
-                <a:latin typeface="Instrument Sans"/>
+                <a:latin typeface="Work Sans"/>
               </a:rPr>
               <a:t>Hábitos de higiene oral en estudiantes de odontología de la Universidad de Chile. SciELO. https://www.scielo.cl/scielo.php?script=sci_arttext&amp;pid=S0719-01072010000100002</a:t>
             </a:r>
@@ -7542,7 +7542,7 @@
         </p:nvSpPr>
         <p:spPr>
           <a:xfrm>
-            <a:off x="990600" y="4484036"/>
+            <a:off x="990600" y="4484464"/>
             <a:ext cx="10987278" cy="241300"/>
           </a:xfrm>
           <a:prstGeom prst="rect">
@@ -7562,11 +7562,11 @@
               </a:lnSpc>
             </a:pPr>
             <a:r>
-              <a:rPr b="0" i="0" sz="1100">
+              <a:rPr b="0" i="0" sz="1010">
                 <a:solidFill>
                   <a:srgbClr val="13294B"/>
                 </a:solidFill>
-                <a:latin typeface="Instrument Sans"/>
+                <a:latin typeface="Work Sans"/>
               </a:rPr>
               <a:t>José, V. C. M. (2025). Gestión educativa y salud bucal en los estudiantes de la Universidad del Azuay. Universidad del Azuay.</a:t>
             </a:r>
@@ -7620,7 +7620,7 @@
         </p:nvSpPr>
         <p:spPr>
           <a:xfrm>
-            <a:off x="990600" y="4814236"/>
+            <a:off x="990600" y="4814664"/>
             <a:ext cx="10987278" cy="431800"/>
           </a:xfrm>
           <a:prstGeom prst="rect">
@@ -7640,11 +7640,11 @@
               </a:lnSpc>
             </a:pPr>
             <a:r>
-              <a:rPr b="0" i="0" sz="1100">
+              <a:rPr b="0" i="0" sz="1019">
                 <a:solidFill>
                   <a:srgbClr val="13294B"/>
                 </a:solidFill>
-                <a:latin typeface="Instrument Sans"/>
+                <a:latin typeface="Work Sans"/>
               </a:rPr>
               <a:t>Ravishankar, T. L., Ain, T. S., &amp; Gowhar, O. (2014). Effect of academic stress on plaque and gingival health among dental students of Moradabad, India. Journal of International Academy of Periodontology, 16(4), 115–120.</a:t>
             </a:r>
@@ -7896,7 +7896,7 @@
         </p:nvSpPr>
         <p:spPr>
           <a:xfrm>
-            <a:off x="558800" y="3374244"/>
+            <a:off x="558800" y="3374757"/>
             <a:ext cx="5911850" cy="736600"/>
           </a:xfrm>
           <a:prstGeom prst="rect">
@@ -7916,11 +7916,11 @@
               </a:lnSpc>
             </a:pPr>
             <a:r>
-              <a:rPr b="0" i="0" sz="1250">
+              <a:rPr b="0" i="0" sz="1140">
                 <a:solidFill>
                   <a:srgbClr val="556079"/>
                 </a:solidFill>
-                <a:latin typeface="Instrument Sans"/>
+                <a:latin typeface="Work Sans"/>
               </a:rPr>
               <a:t>La evidencia teórica y empírica respalda que el tiempo disponible condiciona la higiene bucal. El estudio busca comprobarlo con datos de los propios estudiantes.</a:t>
             </a:r>
@@ -8208,31 +8208,31 @@
         </p:nvSpPr>
         <p:spPr>
           <a:xfrm>
-            <a:off x="558800" y="5915469"/>
-            <a:ext cx="7721930" cy="147193"/>
-          </a:xfrm>
-          <a:prstGeom prst="rect">
-            <a:avLst/>
-          </a:prstGeom>
-          <a:noFill/>
-        </p:spPr>
-        <p:txBody>
-          <a:bodyPr wrap="none" lIns="0" rIns="0" tIns="0" bIns="0" anchor="t">
-            <a:noAutofit/>
-          </a:bodyPr>
-          <a:lstStyle/>
-          <a:p>
-            <a:pPr algn="l">
-              <a:lnSpc>
-                <a:spcPct val="100000"/>
-              </a:lnSpc>
-            </a:pPr>
-            <a:r>
-              <a:rPr b="0" i="0" sz="950">
+            <a:off x="558800" y="5929744"/>
+            <a:ext cx="7721930" cy="129604"/>
+          </a:xfrm>
+          <a:prstGeom prst="rect">
+            <a:avLst/>
+          </a:prstGeom>
+          <a:noFill/>
+        </p:spPr>
+        <p:txBody>
+          <a:bodyPr wrap="none" lIns="0" rIns="0" tIns="0" bIns="0" anchor="t">
+            <a:noAutofit/>
+          </a:bodyPr>
+          <a:lstStyle/>
+          <a:p>
+            <a:pPr algn="l">
+              <a:lnSpc>
+                <a:spcPct val="100000"/>
+              </a:lnSpc>
+            </a:pPr>
+            <a:r>
+              <a:rPr b="0" i="0" sz="869">
                 <a:solidFill>
                   <a:srgbClr val="13294B"/>
                 </a:solidFill>
-                <a:latin typeface="Instrument Sans"/>
+                <a:latin typeface="Work Sans"/>
               </a:rPr>
               <a:t>Romero Elías Esmeralda · Rodríguez Esquivel Megan · Nolasco Mejia Luis Diego · Esquivel Soria Pablo · Rodríguez Hernández Tania</a:t>
             </a:r>
@@ -9438,7 +9438,7 @@
         </p:nvSpPr>
         <p:spPr>
           <a:xfrm>
-            <a:off x="3810000" y="3572239"/>
+            <a:off x="3810000" y="3572695"/>
             <a:ext cx="2379980" cy="660400"/>
           </a:xfrm>
           <a:prstGeom prst="rect">
@@ -9458,11 +9458,11 @@
               </a:lnSpc>
             </a:pPr>
             <a:r>
-              <a:rPr b="0" i="0" sz="1200">
+              <a:rPr b="0" i="0" sz="1100">
                 <a:solidFill>
                   <a:srgbClr val="13294B"/>
                 </a:solidFill>
-                <a:latin typeface="Instrument Sans"/>
+                <a:latin typeface="Work Sans"/>
               </a:rPr>
               <a:t>de la población en México ha padecido caries o enfermedades de las encías.</a:t>
             </a:r>
@@ -9555,7 +9555,7 @@
         </p:nvSpPr>
         <p:spPr>
           <a:xfrm>
-            <a:off x="6858000" y="2226039"/>
+            <a:off x="6858000" y="2226495"/>
             <a:ext cx="4943856" cy="660400"/>
           </a:xfrm>
           <a:prstGeom prst="rect">
@@ -9575,11 +9575,11 @@
               </a:lnSpc>
             </a:pPr>
             <a:r>
-              <a:rPr b="0" i="0" sz="1150">
+              <a:rPr b="0" i="0" sz="1040">
                 <a:solidFill>
                   <a:srgbClr val="13294B"/>
                 </a:solidFill>
-                <a:latin typeface="Instrument Sans"/>
+                <a:latin typeface="Work Sans"/>
               </a:rPr>
               <a:t>Las enfermedades bucodentales —como la caries y la enfermedad periodontal— son un problema de salud pública mundial por su alta prevalencia y su impacto en la masticación, el habla y la estética.</a:t>
             </a:r>
@@ -9633,7 +9633,7 @@
         </p:nvSpPr>
         <p:spPr>
           <a:xfrm>
-            <a:off x="6858000" y="3470639"/>
+            <a:off x="6858000" y="3471095"/>
             <a:ext cx="4943856" cy="457200"/>
           </a:xfrm>
           <a:prstGeom prst="rect">
@@ -9653,11 +9653,11 @@
               </a:lnSpc>
             </a:pPr>
             <a:r>
-              <a:rPr b="0" i="0" sz="1150">
+              <a:rPr b="0" i="0" sz="1060">
                 <a:solidFill>
                   <a:srgbClr val="13294B"/>
                 </a:solidFill>
-                <a:latin typeface="Instrument Sans"/>
+                <a:latin typeface="Work Sans"/>
               </a:rPr>
               <a:t>Prevenirlas depende de hábitos de higiene oral que exigen constancia, técnica correcta y, de manera crucial, tiempo para realizarlos.</a:t>
             </a:r>
@@ -11472,7 +11472,7 @@
         </p:nvSpPr>
         <p:spPr>
           <a:xfrm>
-            <a:off x="558800" y="4852336"/>
+            <a:off x="558800" y="4852764"/>
             <a:ext cx="5519420" cy="431800"/>
           </a:xfrm>
           <a:prstGeom prst="rect">
@@ -11492,11 +11492,11 @@
               </a:lnSpc>
             </a:pPr>
             <a:r>
-              <a:rPr b="0" i="1" sz="1100">
+              <a:rPr b="0" i="1" sz="1000">
                 <a:solidFill>
                   <a:srgbClr val="556079"/>
                 </a:solidFill>
-                <a:latin typeface="Instrument Sans"/>
+                <a:latin typeface="Work Sans"/>
               </a:rPr>
               <a:t>Es una etapa de transición: cambian las rutinas, las responsabilidades y los hábitos de autocuidado.</a:t>
             </a:r>
@@ -12333,7 +12333,7 @@
         </p:nvSpPr>
         <p:spPr>
           <a:xfrm>
-            <a:off x="762000" y="3572083"/>
+            <a:off x="762000" y="3572467"/>
             <a:ext cx="2353818" cy="393700"/>
           </a:xfrm>
           <a:prstGeom prst="rect">
@@ -12353,11 +12353,11 @@
               </a:lnSpc>
             </a:pPr>
             <a:r>
-              <a:rPr b="0" i="0" sz="1000">
+              <a:rPr b="0" i="0" sz="940">
                 <a:solidFill>
                   <a:srgbClr val="556079"/>
                 </a:solidFill>
-                <a:latin typeface="Instrument Sans"/>
+                <a:latin typeface="Work Sans"/>
               </a:rPr>
               <a:t>Exigencias universitarias, exámenes y empleo.</a:t>
             </a:r>
@@ -12450,7 +12450,7 @@
         </p:nvSpPr>
         <p:spPr>
           <a:xfrm>
-            <a:off x="4470400" y="2911683"/>
+            <a:off x="4470400" y="2912067"/>
             <a:ext cx="3374136" cy="222250"/>
           </a:xfrm>
           <a:prstGeom prst="rect">
@@ -12470,11 +12470,11 @@
               </a:lnSpc>
             </a:pPr>
             <a:r>
-              <a:rPr b="0" i="0" sz="1000">
+              <a:rPr b="0" i="0" sz="900">
                 <a:solidFill>
                   <a:srgbClr val="556079"/>
                 </a:solidFill>
-                <a:latin typeface="Instrument Sans"/>
+                <a:latin typeface="Work Sans"/>
               </a:rPr>
               <a:t>Se reducen la frecuencia y la calidad del cepillado.</a:t>
             </a:r>
@@ -12567,7 +12567,7 @@
         </p:nvSpPr>
         <p:spPr>
           <a:xfrm>
-            <a:off x="4470400" y="4537283"/>
+            <a:off x="4470400" y="4537667"/>
             <a:ext cx="3374136" cy="393700"/>
           </a:xfrm>
           <a:prstGeom prst="rect">
@@ -12587,11 +12587,11 @@
               </a:lnSpc>
             </a:pPr>
             <a:r>
-              <a:rPr b="0" i="0" sz="1000">
+              <a:rPr b="0" i="0" sz="930">
                 <a:solidFill>
                   <a:srgbClr val="556079"/>
                 </a:solidFill>
-                <a:latin typeface="Instrument Sans"/>
+                <a:latin typeface="Work Sans"/>
               </a:rPr>
               <a:t>Cambios inmunológicos que favorecen la inflamación gingival y la placa.</a:t>
             </a:r>
@@ -12684,7 +12684,7 @@
         </p:nvSpPr>
         <p:spPr>
           <a:xfrm>
-            <a:off x="9169400" y="3572083"/>
+            <a:off x="9169400" y="3572467"/>
             <a:ext cx="2353818" cy="393700"/>
           </a:xfrm>
           <a:prstGeom prst="rect">
@@ -12704,11 +12704,11 @@
               </a:lnSpc>
             </a:pPr>
             <a:r>
-              <a:rPr b="0" i="0" sz="1000">
+              <a:rPr b="0" i="0" sz="919">
                 <a:solidFill>
                   <a:srgbClr val="556079"/>
                 </a:solidFill>
-                <a:latin typeface="Instrument Sans"/>
+                <a:latin typeface="Work Sans"/>
               </a:rPr>
               <a:t>Mayor riesgo de caries y enfermedad de las encías.</a:t>
             </a:r>
@@ -12801,7 +12801,7 @@
         </p:nvSpPr>
         <p:spPr>
           <a:xfrm>
-            <a:off x="2971800" y="5601636"/>
+            <a:off x="2971800" y="5602064"/>
             <a:ext cx="8920480" cy="431800"/>
           </a:xfrm>
           <a:prstGeom prst="rect">
@@ -12821,11 +12821,11 @@
               </a:lnSpc>
             </a:pPr>
             <a:r>
-              <a:rPr b="0" i="0" sz="1100">
+              <a:rPr b="0" i="0" sz="1010">
                 <a:solidFill>
                   <a:srgbClr val="13294B"/>
                 </a:solidFill>
-                <a:latin typeface="Instrument Sans"/>
+                <a:latin typeface="Work Sans"/>
               </a:rPr>
               <a:t>Ravishankar, Ain y Gowhar (2014): el estrés académico se asoció con mayor prevalencia de enfermedad periodontal y peor higiene oral en estudiantes.</a:t>
             </a:r>
@@ -13194,8 +13194,8 @@
         </p:nvSpPr>
         <p:spPr>
           <a:xfrm>
-            <a:off x="1344228" y="4106291"/>
-            <a:ext cx="2391543" cy="170434"/>
+            <a:off x="1344228" y="4116603"/>
+            <a:ext cx="2391543" cy="157909"/>
           </a:xfrm>
           <a:prstGeom prst="rect">
             <a:avLst/>
@@ -13214,11 +13214,11 @@
               </a:lnSpc>
             </a:pPr>
             <a:r>
-              <a:rPr b="1" i="0" sz="1100">
+              <a:rPr b="1" i="0" sz="1060">
                 <a:solidFill>
                   <a:srgbClr val="13294B"/>
                 </a:solidFill>
-                <a:latin typeface="Instrument Sans"/>
+                <a:latin typeface="Work Sans"/>
               </a:rPr>
               <a:t>Conocimiento sobre el cepillado</a:t>
             </a:r>
@@ -13350,8 +13350,8 @@
         </p:nvSpPr>
         <p:spPr>
           <a:xfrm>
-            <a:off x="5185836" y="4106291"/>
-            <a:ext cx="1820326" cy="170434"/>
+            <a:off x="5185836" y="4117784"/>
+            <a:ext cx="1820326" cy="156419"/>
           </a:xfrm>
           <a:prstGeom prst="rect">
             <a:avLst/>
@@ -13370,11 +13370,11 @@
               </a:lnSpc>
             </a:pPr>
             <a:r>
-              <a:rPr b="1" i="0" sz="1100">
+              <a:rPr b="1" i="0" sz="1050">
                 <a:solidFill>
                   <a:srgbClr val="13294B"/>
                 </a:solidFill>
-                <a:latin typeface="Instrument Sans"/>
+                <a:latin typeface="Work Sans"/>
               </a:rPr>
               <a:t>Frecuencia del cepillado</a:t>
             </a:r>
@@ -13506,8 +13506,8 @@
         </p:nvSpPr>
         <p:spPr>
           <a:xfrm>
-            <a:off x="8712793" y="4106291"/>
-            <a:ext cx="1878413" cy="170434"/>
+            <a:off x="8712793" y="4115422"/>
+            <a:ext cx="1878413" cy="159398"/>
           </a:xfrm>
           <a:prstGeom prst="rect">
             <a:avLst/>
@@ -13526,11 +13526,11 @@
               </a:lnSpc>
             </a:pPr>
             <a:r>
-              <a:rPr b="1" i="0" sz="1100">
+              <a:rPr b="1" i="0" sz="1070">
                 <a:solidFill>
                   <a:srgbClr val="13294B"/>
                 </a:solidFill>
-                <a:latin typeface="Instrument Sans"/>
+                <a:latin typeface="Work Sans"/>
               </a:rPr>
               <a:t>Disponibilidad de tiempo</a:t>
             </a:r>
@@ -13662,7 +13662,7 @@
         </p:nvSpPr>
         <p:spPr>
           <a:xfrm>
-            <a:off x="2463800" y="5073285"/>
+            <a:off x="2463800" y="5073698"/>
             <a:ext cx="3949700" cy="603250"/>
           </a:xfrm>
           <a:prstGeom prst="rect">
@@ -13682,11 +13682,11 @@
               </a:lnSpc>
             </a:pPr>
             <a:r>
-              <a:rPr b="0" i="0" sz="1050">
+              <a:rPr b="0" i="0" sz="960">
                 <a:solidFill>
                   <a:srgbClr val="13294B"/>
                 </a:solidFill>
-                <a:latin typeface="Instrument Sans"/>
+                <a:latin typeface="Work Sans"/>
               </a:rPr>
               <a:t>El problema no ha sido documentado de manera sistemática: se desconoce en qué medida los horarios influyen en el cepillado.</a:t>
             </a:r>
@@ -14172,7 +14172,7 @@
         </p:nvSpPr>
         <p:spPr>
           <a:xfrm>
-            <a:off x="762000" y="3533983"/>
+            <a:off x="762000" y="3534367"/>
             <a:ext cx="2170684" cy="393700"/>
           </a:xfrm>
           <a:prstGeom prst="rect">
@@ -14192,11 +14192,11 @@
               </a:lnSpc>
             </a:pPr>
             <a:r>
-              <a:rPr b="0" i="0" sz="1000">
+              <a:rPr b="0" i="0" sz="930">
                 <a:solidFill>
                   <a:srgbClr val="556079"/>
                 </a:solidFill>
-                <a:latin typeface="Instrument Sans"/>
+                <a:latin typeface="Work Sans"/>
               </a:rPr>
               <a:t>Jornadas prolongadas, exámenes y empleo.</a:t>
             </a:r>
@@ -14289,7 +14289,7 @@
         </p:nvSpPr>
         <p:spPr>
           <a:xfrm>
-            <a:off x="3623310" y="3267283"/>
+            <a:off x="3623310" y="3267667"/>
             <a:ext cx="2170684" cy="393700"/>
           </a:xfrm>
           <a:prstGeom prst="rect">
@@ -14309,11 +14309,11 @@
               </a:lnSpc>
             </a:pPr>
             <a:r>
-              <a:rPr b="0" i="0" sz="1000">
+              <a:rPr b="0" i="0" sz="919">
                 <a:solidFill>
                   <a:srgbClr val="556079"/>
                 </a:solidFill>
-                <a:latin typeface="Instrument Sans"/>
+                <a:latin typeface="Work Sans"/>
               </a:rPr>
               <a:t>Barrera estructural para el autocuidado.</a:t>
             </a:r>
@@ -14406,7 +14406,7 @@
         </p:nvSpPr>
         <p:spPr>
           <a:xfrm>
-            <a:off x="6484620" y="3800683"/>
+            <a:off x="6484620" y="3801067"/>
             <a:ext cx="2170684" cy="393700"/>
           </a:xfrm>
           <a:prstGeom prst="rect">
@@ -14426,11 +14426,11 @@
               </a:lnSpc>
             </a:pPr>
             <a:r>
-              <a:rPr b="0" i="0" sz="1000">
+              <a:rPr b="0" i="0" sz="919">
                 <a:solidFill>
                   <a:srgbClr val="556079"/>
                 </a:solidFill>
-                <a:latin typeface="Instrument Sans"/>
+                <a:latin typeface="Work Sans"/>
               </a:rPr>
               <a:t>Apresurado u omitido durante la jornada.</a:t>
             </a:r>
@@ -14523,7 +14523,7 @@
         </p:nvSpPr>
         <p:spPr>
           <a:xfrm>
-            <a:off x="9345930" y="3267283"/>
+            <a:off x="9345930" y="3267667"/>
             <a:ext cx="2170684" cy="393700"/>
           </a:xfrm>
           <a:prstGeom prst="rect">
@@ -14543,11 +14543,11 @@
               </a:lnSpc>
             </a:pPr>
             <a:r>
-              <a:rPr b="0" i="0" sz="1000">
+              <a:rPr b="0" i="0" sz="930">
                 <a:solidFill>
                   <a:srgbClr val="556079"/>
                 </a:solidFill>
-                <a:latin typeface="Instrument Sans"/>
+                <a:latin typeface="Work Sans"/>
               </a:rPr>
               <a:t>Placa, caries y enfermedad periodontal.</a:t>
             </a:r>
@@ -15189,31 +15189,31 @@
         </p:nvSpPr>
         <p:spPr>
           <a:xfrm>
-            <a:off x="6731000" y="2347150"/>
-            <a:ext cx="4705658" cy="162687"/>
-          </a:xfrm>
-          <a:prstGeom prst="rect">
-            <a:avLst/>
-          </a:prstGeom>
-          <a:noFill/>
-        </p:spPr>
-        <p:txBody>
-          <a:bodyPr wrap="none" lIns="0" rIns="0" tIns="0" bIns="0" anchor="t">
-            <a:noAutofit/>
-          </a:bodyPr>
-          <a:lstStyle/>
-          <a:p>
-            <a:pPr algn="l">
-              <a:lnSpc>
-                <a:spcPct val="100000"/>
-              </a:lnSpc>
-            </a:pPr>
-            <a:r>
-              <a:rPr b="0" i="0" sz="1050">
+            <a:off x="6731000" y="2364295"/>
+            <a:ext cx="4705658" cy="141522"/>
+          </a:xfrm>
+          <a:prstGeom prst="rect">
+            <a:avLst/>
+          </a:prstGeom>
+          <a:noFill/>
+        </p:spPr>
+        <p:txBody>
+          <a:bodyPr wrap="none" lIns="0" rIns="0" tIns="0" bIns="0" anchor="t">
+            <a:noAutofit/>
+          </a:bodyPr>
+          <a:lstStyle/>
+          <a:p>
+            <a:pPr algn="l">
+              <a:lnSpc>
+                <a:spcPct val="100000"/>
+              </a:lnSpc>
+            </a:pPr>
+            <a:r>
+              <a:rPr b="0" i="0" sz="950">
                 <a:solidFill>
                   <a:srgbClr val="13294B"/>
                 </a:solidFill>
-                <a:latin typeface="Instrument Sans"/>
+                <a:latin typeface="Work Sans"/>
               </a:rPr>
               <a:t>Horas diarias en clases, tareas y trabajo; percepción de falta de tiempo.</a:t>
             </a:r>
@@ -15345,31 +15345,31 @@
         </p:nvSpPr>
         <p:spPr>
           <a:xfrm>
-            <a:off x="6731000" y="3007550"/>
-            <a:ext cx="3441468" cy="162687"/>
-          </a:xfrm>
-          <a:prstGeom prst="rect">
-            <a:avLst/>
-          </a:prstGeom>
-          <a:noFill/>
-        </p:spPr>
-        <p:txBody>
-          <a:bodyPr wrap="none" lIns="0" rIns="0" tIns="0" bIns="0" anchor="t">
-            <a:noAutofit/>
-          </a:bodyPr>
-          <a:lstStyle/>
-          <a:p>
-            <a:pPr algn="l">
-              <a:lnSpc>
-                <a:spcPct val="100000"/>
-              </a:lnSpc>
-            </a:pPr>
-            <a:r>
-              <a:rPr b="0" i="0" sz="1050">
+            <a:off x="6731000" y="3024695"/>
+            <a:ext cx="3441468" cy="141522"/>
+          </a:xfrm>
+          <a:prstGeom prst="rect">
+            <a:avLst/>
+          </a:prstGeom>
+          <a:noFill/>
+        </p:spPr>
+        <p:txBody>
+          <a:bodyPr wrap="none" lIns="0" rIns="0" tIns="0" bIns="0" anchor="t">
+            <a:noAutofit/>
+          </a:bodyPr>
+          <a:lstStyle/>
+          <a:p>
+            <a:pPr algn="l">
+              <a:lnSpc>
+                <a:spcPct val="100000"/>
+              </a:lnSpc>
+            </a:pPr>
+            <a:r>
+              <a:rPr b="0" i="0" sz="950">
                 <a:solidFill>
                   <a:srgbClr val="13294B"/>
                 </a:solidFill>
-                <a:latin typeface="Instrument Sans"/>
+                <a:latin typeface="Work Sans"/>
               </a:rPr>
               <a:t>Turno y si el estudiante trabaja además de estudiar.</a:t>
             </a:r>
@@ -15501,31 +15501,31 @@
         </p:nvSpPr>
         <p:spPr>
           <a:xfrm>
-            <a:off x="6731000" y="3667950"/>
-            <a:ext cx="3300619" cy="162687"/>
-          </a:xfrm>
-          <a:prstGeom prst="rect">
-            <a:avLst/>
-          </a:prstGeom>
-          <a:noFill/>
-        </p:spPr>
-        <p:txBody>
-          <a:bodyPr wrap="none" lIns="0" rIns="0" tIns="0" bIns="0" anchor="t">
-            <a:noAutofit/>
-          </a:bodyPr>
-          <a:lstStyle/>
-          <a:p>
-            <a:pPr algn="l">
-              <a:lnSpc>
-                <a:spcPct val="100000"/>
-              </a:lnSpc>
-            </a:pPr>
-            <a:r>
-              <a:rPr b="0" i="0" sz="1050">
+            <a:off x="6731000" y="3682733"/>
+            <a:ext cx="3300619" cy="144501"/>
+          </a:xfrm>
+          <a:prstGeom prst="rect">
+            <a:avLst/>
+          </a:prstGeom>
+          <a:noFill/>
+        </p:spPr>
+        <p:txBody>
+          <a:bodyPr wrap="none" lIns="0" rIns="0" tIns="0" bIns="0" anchor="t">
+            <a:noAutofit/>
+          </a:bodyPr>
+          <a:lstStyle/>
+          <a:p>
+            <a:pPr algn="l">
+              <a:lnSpc>
+                <a:spcPct val="100000"/>
+              </a:lnSpc>
+            </a:pPr>
+            <a:r>
+              <a:rPr b="0" i="0" sz="969">
                 <a:solidFill>
                   <a:srgbClr val="13294B"/>
                 </a:solidFill>
-                <a:latin typeface="Instrument Sans"/>
+                <a:latin typeface="Work Sans"/>
               </a:rPr>
               <a:t>Coeficiente r y prueba de significancia (p &lt; 0.05).</a:t>
             </a:r>
@@ -15657,31 +15657,31 @@
         </p:nvSpPr>
         <p:spPr>
           <a:xfrm>
-            <a:off x="6731000" y="4328350"/>
-            <a:ext cx="5191431" cy="162687"/>
-          </a:xfrm>
-          <a:prstGeom prst="rect">
-            <a:avLst/>
-          </a:prstGeom>
-          <a:noFill/>
-        </p:spPr>
-        <p:txBody>
-          <a:bodyPr wrap="none" lIns="0" rIns="0" tIns="0" bIns="0" anchor="t">
-            <a:noAutofit/>
-          </a:bodyPr>
-          <a:lstStyle/>
-          <a:p>
-            <a:pPr algn="l">
-              <a:lnSpc>
-                <a:spcPct val="100000"/>
-              </a:lnSpc>
-            </a:pPr>
-            <a:r>
-              <a:rPr b="0" i="0" sz="1050">
+            <a:off x="6731000" y="4344314"/>
+            <a:ext cx="5191431" cy="143012"/>
+          </a:xfrm>
+          <a:prstGeom prst="rect">
+            <a:avLst/>
+          </a:prstGeom>
+          <a:noFill/>
+        </p:spPr>
+        <p:txBody>
+          <a:bodyPr wrap="none" lIns="0" rIns="0" tIns="0" bIns="0" anchor="t">
+            <a:noAutofit/>
+          </a:bodyPr>
+          <a:lstStyle/>
+          <a:p>
+            <a:pPr algn="l">
+              <a:lnSpc>
+                <a:spcPct val="100000"/>
+              </a:lnSpc>
+            </a:pPr>
+            <a:r>
+              <a:rPr b="0" i="0" sz="960">
                 <a:solidFill>
                   <a:srgbClr val="13294B"/>
                 </a:solidFill>
-                <a:latin typeface="Instrument Sans"/>
+                <a:latin typeface="Work Sans"/>
               </a:rPr>
               <a:t>Frecuencia y momento del cepillado, hilo dental, enjuague y visitas al dentista.</a:t>
             </a:r>
@@ -15813,31 +15813,31 @@
         </p:nvSpPr>
         <p:spPr>
           <a:xfrm>
-            <a:off x="6731000" y="4988750"/>
-            <a:ext cx="3831757" cy="162687"/>
-          </a:xfrm>
-          <a:prstGeom prst="rect">
-            <a:avLst/>
-          </a:prstGeom>
-          <a:noFill/>
-        </p:spPr>
-        <p:txBody>
-          <a:bodyPr wrap="none" lIns="0" rIns="0" tIns="0" bIns="0" anchor="t">
-            <a:noAutofit/>
-          </a:bodyPr>
-          <a:lstStyle/>
-          <a:p>
-            <a:pPr algn="l">
-              <a:lnSpc>
-                <a:spcPct val="100000"/>
-              </a:lnSpc>
-            </a:pPr>
-            <a:r>
-              <a:rPr b="0" i="0" sz="1050">
+            <a:off x="6731000" y="5005895"/>
+            <a:ext cx="3831757" cy="141522"/>
+          </a:xfrm>
+          <a:prstGeom prst="rect">
+            <a:avLst/>
+          </a:prstGeom>
+          <a:noFill/>
+        </p:spPr>
+        <p:txBody>
+          <a:bodyPr wrap="none" lIns="0" rIns="0" tIns="0" bIns="0" anchor="t">
+            <a:noAutofit/>
+          </a:bodyPr>
+          <a:lstStyle/>
+          <a:p>
+            <a:pPr algn="l">
+              <a:lnSpc>
+                <a:spcPct val="100000"/>
+              </a:lnSpc>
+            </a:pPr>
+            <a:r>
+              <a:rPr b="0" i="0" sz="950">
                 <a:solidFill>
                   <a:srgbClr val="13294B"/>
                 </a:solidFill>
-                <a:latin typeface="Instrument Sans"/>
+                <a:latin typeface="Work Sans"/>
               </a:rPr>
               <a:t>Estudiantes de 18 a 23 años de distintas carreras y turnos.</a:t>
             </a:r>
@@ -16008,31 +16008,31 @@
         </p:nvSpPr>
         <p:spPr>
           <a:xfrm>
-            <a:off x="6731000" y="5649150"/>
-            <a:ext cx="4155077" cy="162687"/>
-          </a:xfrm>
-          <a:prstGeom prst="rect">
-            <a:avLst/>
-          </a:prstGeom>
-          <a:noFill/>
-        </p:spPr>
-        <p:txBody>
-          <a:bodyPr wrap="none" lIns="0" rIns="0" tIns="0" bIns="0" anchor="t">
-            <a:noAutofit/>
-          </a:bodyPr>
-          <a:lstStyle/>
-          <a:p>
-            <a:pPr algn="l">
-              <a:lnSpc>
-                <a:spcPct val="100000"/>
-              </a:lnSpc>
-            </a:pPr>
-            <a:r>
-              <a:rPr b="0" i="0" sz="1050">
+            <a:off x="6731000" y="5665114"/>
+            <a:ext cx="4155077" cy="143012"/>
+          </a:xfrm>
+          <a:prstGeom prst="rect">
+            <a:avLst/>
+          </a:prstGeom>
+          <a:noFill/>
+        </p:spPr>
+        <p:txBody>
+          <a:bodyPr wrap="none" lIns="0" rIns="0" tIns="0" bIns="0" anchor="t">
+            <a:noAutofit/>
+          </a:bodyPr>
+          <a:lstStyle/>
+          <a:p>
+            <a:pPr algn="l">
+              <a:lnSpc>
+                <a:spcPct val="100000"/>
+              </a:lnSpc>
+            </a:pPr>
+            <a:r>
+              <a:rPr b="0" i="0" sz="960">
                 <a:solidFill>
                   <a:srgbClr val="13294B"/>
                 </a:solidFill>
-                <a:latin typeface="Instrument Sans"/>
+                <a:latin typeface="Work Sans"/>
               </a:rPr>
               <a:t>Un coeficiente r positivo: menos horas libres, menos cepillado.</a:t>
             </a:r>

</xml_diff>